<commit_message>
Add new media files and update RA03 presentation in documentation
</commit_message>
<xml_diff>
--- a/docs/RA03_Complexidade.pptx
+++ b/docs/RA03_Complexidade.pptx
@@ -2864,9 +2864,15 @@
   <p:cSld name="Slide 1">
     <p:bg>
       <p:bgPr>
-        <a:solidFill>
-          <a:srgbClr val="020617"/>
-        </a:solidFill>
+        <a:blipFill dpi="0" rotWithShape="1">
+          <a:blip r:embed="rId3">
+            <a:lum/>
+          </a:blip>
+          <a:srcRect/>
+          <a:stretch>
+            <a:fillRect/>
+          </a:stretch>
+        </a:blipFill>
         <a:effectLst/>
       </p:bgPr>
     </p:bg>
@@ -2884,6 +2890,60 @@
           <a:chExt cx="0" cy="0"/>
         </a:xfrm>
       </p:grpSpPr>
+      <p:sp>
+        <p:nvSpPr>
+          <p:cNvPr id="19" name="Retângulo 18">
+            <a:extLst>
+              <a:ext uri="{FF2B5EF4-FFF2-40B4-BE49-F238E27FC236}">
+                <a16:creationId xmlns:a16="http://schemas.microsoft.com/office/drawing/2014/main" id="{53E6DF89-4858-7248-1B80-B586AC8080B6}"/>
+              </a:ext>
+            </a:extLst>
+          </p:cNvPr>
+          <p:cNvSpPr/>
+          <p:nvPr/>
+        </p:nvSpPr>
+        <p:spPr>
+          <a:xfrm>
+            <a:off x="1" y="1"/>
+            <a:ext cx="18288000" cy="10287000"/>
+          </a:xfrm>
+          <a:prstGeom prst="rect">
+            <a:avLst/>
+          </a:prstGeom>
+          <a:solidFill>
+            <a:schemeClr val="tx1">
+              <a:alpha val="82000"/>
+            </a:schemeClr>
+          </a:solidFill>
+          <a:ln>
+            <a:noFill/>
+          </a:ln>
+        </p:spPr>
+        <p:style>
+          <a:lnRef idx="2">
+            <a:schemeClr val="accent1">
+              <a:shade val="15000"/>
+            </a:schemeClr>
+          </a:lnRef>
+          <a:fillRef idx="1">
+            <a:schemeClr val="accent1"/>
+          </a:fillRef>
+          <a:effectRef idx="0">
+            <a:schemeClr val="accent1"/>
+          </a:effectRef>
+          <a:fontRef idx="minor">
+            <a:schemeClr val="lt1"/>
+          </a:fontRef>
+        </p:style>
+        <p:txBody>
+          <a:bodyPr rtlCol="0" anchor="ctr"/>
+          <a:lstStyle/>
+          <a:p>
+            <a:pPr algn="ctr"/>
+            <a:endParaRPr lang="pt-BR"/>
+          </a:p>
+        </p:txBody>
+      </p:sp>
       <p:sp>
         <p:nvSpPr>
           <p:cNvPr id="2" name="Shape 0"/>

</xml_diff>